<commit_message>
fix: bake custGeom scaling into path coordinates
预览丢内容的根因：custGeom 自带 EMU 坐标空间，上游把坐标原样留在 d 里、
只挂一个 EMU→px 的 transform="scale(1.05e-4)"；resvg 对有效缩放 ≤ 1/4096
的 path 整条丢弃，于是公司模板里所有自定义图形——卡片标题条、平行四边形、
直角三角形、菱形——在预览里静默消失，不报错、PNG 依然合法、门禁全绿。

- 补丁：新增 scalePathCommands，按 scaleX/scaleY 逐点重写 d，不再挂 transform
  （15 → 17 hunk）。A 圆弧在非等比缩放下是近似，但它今天本来就被整条丢弃。
- 缓存：预览只按 versionId 键控，接不到「渲染器换了但成果没变」的信号，
  修好缺陷后用户仍看到旧图。改为 PptxRenderer 携带 previewRevision，
  落盘写 thumbnails/.revision，缺失或不一致即整目录作废重建；标记最后写。
- 配置：eslint ignores 补 .betterwork/**。该目录已被 git 与 Prettier 忽略，
  且装着应用运行时生成的 tasks/，Skill 跑一次任务就能把 npm run verify 刷红。

几何回归用例先做正向控制（确认元素确实在 SVG 里）再断言坐标量级与无 transform；
两条 revision 用例在拆掉作废条件后都会失败。npm run verify 退出 0。
</commit_message>
<xml_diff>
--- a/apps/desktop/src/main/infrastructure/fixtures/slide-preview-fixture.pptx
+++ b/apps/desktop/src/main/infrastructure/fixtures/slide-preview-fixture.pptx
@@ -3143,7 +3143,7 @@
           <a:lstStyle/>
           <a:p>
             <a:r>
-              <a:rPr sz="2200" b="0">
+              <a:rPr sz="2000" b="0">
                 <a:latin typeface="Microsoft YaHei"/>
               </a:rPr>
               <a:t>一、收入结构持续改善</a:t>
@@ -3151,7 +3151,7 @@
           </a:p>
           <a:p>
             <a:r>
-              <a:rPr sz="2200" b="0">
+              <a:rPr sz="2000" b="0">
                 <a:latin typeface="Microsoft YaHei"/>
               </a:rPr>
               <a:t>二、交付效率提升明显</a:t>
@@ -3159,7 +3159,7 @@
           </a:p>
           <a:p>
             <a:r>
-              <a:rPr sz="2200" b="0">
+              <a:rPr sz="2000" b="0">
                 <a:latin typeface="Microsoft YaHei"/>
               </a:rPr>
               <a:t>三、下季度重点：规模化复制</a:t>
@@ -3224,8 +3224,8 @@
         </p:nvSpPr>
         <p:spPr>
           <a:xfrm>
-            <a:off x="731520" y="2103120"/>
-            <a:ext cx="10698480" cy="1828800"/>
+            <a:off x="731520" y="2194560"/>
+            <a:ext cx="10698480" cy="2286000"/>
           </a:xfrm>
           <a:prstGeom prst="rect">
             <a:avLst/>
@@ -3239,11 +3239,75 @@
           <a:lstStyle/>
           <a:p>
             <a:r>
-              <a:rPr sz="2000" b="0">
+              <a:rPr sz="1800" b="0">
                 <a:latin typeface="SimSun"/>
               </a:rPr>
               <a:t>标题用黑体，正文用宋体，用于验证两种字体名都能映射到随包字体。</a:t>
             </a:r>
+          </a:p>
+        </p:txBody>
+      </p:sp>
+      <p:sp>
+        <p:nvSpPr>
+          <p:cNvPr id="4" name="Freeform 3"/>
+          <p:cNvSpPr/>
+          <p:nvPr/>
+        </p:nvSpPr>
+        <p:spPr>
+          <a:xfrm>
+            <a:off x="700000" y="4400000"/>
+            <a:ext cx="2700000" cy="600000"/>
+          </a:xfrm>
+          <a:custGeom>
+            <a:avLst/>
+            <a:gdLst/>
+            <a:ahLst/>
+            <a:cxnLst/>
+            <a:rect l="l" t="t" r="r" b="b"/>
+            <a:pathLst>
+              <a:path w="2700000" h="600000">
+                <a:moveTo>
+                  <a:pt x="300000" y="0"/>
+                </a:moveTo>
+                <a:lnTo>
+                  <a:pt x="2700000" y="0"/>
+                </a:lnTo>
+                <a:lnTo>
+                  <a:pt x="2400000" y="600000"/>
+                </a:lnTo>
+                <a:lnTo>
+                  <a:pt x="0" y="600000"/>
+                </a:lnTo>
+                <a:close/>
+              </a:path>
+            </a:pathLst>
+          </a:custGeom>
+          <a:solidFill>
+            <a:srgbClr val="1B4593"/>
+          </a:solidFill>
+          <a:ln>
+            <a:noFill/>
+          </a:ln>
+        </p:spPr>
+        <p:style>
+          <a:lnRef idx="1">
+            <a:schemeClr val="accent1"/>
+          </a:lnRef>
+          <a:fillRef idx="3">
+            <a:schemeClr val="accent1"/>
+          </a:fillRef>
+          <a:effectRef idx="2">
+            <a:schemeClr val="accent1"/>
+          </a:effectRef>
+          <a:fontRef idx="minor">
+            <a:schemeClr val="lt1"/>
+          </a:fontRef>
+        </p:style>
+        <p:txBody>
+          <a:bodyPr rtlCol="0" anchor="ctr"/>
+          <a:lstStyle/>
+          <a:p>
+            <a:pPr algn="ctr"/>
           </a:p>
         </p:txBody>
       </p:sp>

</xml_diff>